<commit_message>
Quick Guides: Prozessbilder, Prozesslandkarte und Kapitelbild je Guide
Jeder Guide erhält ein Prozessbild der Kapitelschritte, eine Prozesslandkarte
mit hervorgehobener Phase und ein Kapitelbild statt der Screenshot-Platzhalter.
Spaltenausgleich auf Seite 2, damit keine Karte in die Fußzeile läuft.

Co-Authored-By: Claude Fable 5.1 <noreply@anthropic.com>
Claude-Session: https://claude.ai/code/session_01EhK4mVLcbJ5LMGgA3j15g8
</commit_message>
<xml_diff>
--- a/docs/quickguides/pptx/01_Quick_Guide_oneSCM_Einfuehrung_und_Ueberblick.pptx
+++ b/docs/quickguides/pptx/01_Quick_Guide_oneSCM_Einfuehrung_und_Ueberblick.pptx
@@ -1213,11 +1213,11 @@
         <p:spPr>
           <a:xfrm>
             <a:off x="201168" y="713232"/>
-            <a:ext cx="4663440" cy="1335024"/>
+            <a:ext cx="4663440" cy="1426464"/>
           </a:xfrm>
           <a:prstGeom prst="roundRect">
             <a:avLst>
-              <a:gd name="adj" fmla="val 6849"/>
+              <a:gd name="adj" fmla="val 6410"/>
             </a:avLst>
           </a:prstGeom>
           <a:solidFill>
@@ -1281,7 +1281,7 @@
         <p:spPr>
           <a:xfrm>
             <a:off x="310896" y="1060704"/>
-            <a:ext cx="2633472" cy="932688"/>
+            <a:ext cx="2633472" cy="1024128"/>
           </a:xfrm>
           <a:prstGeom prst="rect">
             <a:avLst/>
@@ -1402,12 +1402,20 @@
           </a:p>
         </p:txBody>
       </p:sp>
-      <p:sp>
-        <p:nvSpPr>
-          <p:cNvPr id="11" name="Screenshot-Rahmen"/>
-          <p:cNvSpPr/>
-          <p:nvPr/>
-        </p:nvSpPr>
+      <p:pic>
+        <p:nvPicPr>
+          <p:cNvPr id="11" name="Kapitelbild" descr="/tmp/claude-0/-home-user-step2-oneSCM/768b354c-b2c6-524c-b102-2abaf010b0fe/scratchpad/qg/src/img/badge_01.png">    </p:cNvPr>
+          <p:cNvPicPr>
+            <a:picLocks noChangeAspect="1"/>
+          </p:cNvPicPr>
+          <p:nvPr/>
+        </p:nvPicPr>
+        <p:blipFill>
+          <a:blip r:embed="rId3"/>
+          <a:stretch>
+            <a:fillRect/>
+          </a:stretch>
+        </p:blipFill>
         <p:spPr>
           <a:xfrm>
             <a:off x="3035808" y="804672"/>
@@ -1416,82 +1424,17 @@
           <a:prstGeom prst="rect">
             <a:avLst/>
           </a:prstGeom>
-          <a:solidFill>
-            <a:srgbClr val="F3F3F3"/>
-          </a:solidFill>
-          <a:ln w="6350">
-            <a:solidFill>
-              <a:srgbClr val="BFBFBF"/>
-            </a:solidFill>
-            <a:prstDash val="solid"/>
-          </a:ln>
-        </p:spPr>
-      </p:sp>
-      <p:sp>
-        <p:nvSpPr>
-          <p:cNvPr id="12" name="Screenshot-Beschriftung"/>
+        </p:spPr>
+      </p:pic>
+      <p:sp>
+        <p:nvSpPr>
+          <p:cNvPr id="12" name="Hinweis"/>
           <p:cNvSpPr txBox="1"/>
           <p:nvPr/>
         </p:nvSpPr>
         <p:spPr>
           <a:xfrm>
-            <a:off x="3035808" y="804672"/>
-            <a:ext cx="1737360" cy="1051560"/>
-          </a:xfrm>
-          <a:prstGeom prst="rect">
-            <a:avLst/>
-          </a:prstGeom>
-          <a:noFill/>
-          <a:ln/>
-        </p:spPr>
-        <p:txBody>
-          <a:bodyPr wrap="square" lIns="50800" tIns="50800" rIns="50800" bIns="50800" rtlCol="0" anchor="ctr"/>
-          <a:lstStyle/>
-          <a:p>
-            <a:pPr algn="ctr" indent="0" marL="0">
-              <a:buNone/>
-            </a:pPr>
-            <a:r>
-              <a:rPr lang="en-US" sz="700" b="1" dirty="0">
-                <a:solidFill>
-                  <a:srgbClr val="404040"/>
-                </a:solidFill>
-                <a:latin typeface="MB Corpo S Text Office" pitchFamily="34" charset="0"/>
-                <a:ea typeface="MB Corpo S Text Office" pitchFamily="34" charset="-122"/>
-                <a:cs typeface="MB Corpo S Text Office" pitchFamily="34" charset="-120"/>
-              </a:rPr>
-              <a:t>Screenshot</a:t>
-            </a:r>
-            <a:endParaRPr lang="en-US" sz="700" dirty="0"/>
-          </a:p>
-          <a:p>
-            <a:pPr algn="ctr" indent="0" marL="0">
-              <a:buNone/>
-            </a:pPr>
-            <a:r>
-              <a:rPr lang="en-US" sz="700" dirty="0">
-                <a:solidFill>
-                  <a:srgbClr val="404040"/>
-                </a:solidFill>
-                <a:latin typeface="MB Corpo S Text Office" pitchFamily="34" charset="0"/>
-                <a:ea typeface="MB Corpo S Text Office" pitchFamily="34" charset="-122"/>
-                <a:cs typeface="MB Corpo S Text Office" pitchFamily="34" charset="-120"/>
-              </a:rPr>
-              <a:t>Startseite oneSCM</a:t>
-            </a:r>
-            <a:endParaRPr lang="en-US" sz="700" dirty="0"/>
-          </a:p>
-        </p:txBody>
-      </p:sp>
-      <p:sp>
-        <p:nvSpPr>
-          <p:cNvPr id="13" name="Hinweis"/>
-          <p:cNvSpPr txBox="1"/>
-          <p:nvPr/>
-        </p:nvSpPr>
-        <p:spPr>
-          <a:xfrm>
-            <a:off x="201168" y="2157984"/>
+            <a:off x="201168" y="2249424"/>
             <a:ext cx="4663440" cy="329184"/>
           </a:xfrm>
           <a:prstGeom prst="rect">
@@ -1524,13 +1467,13 @@
       </p:sp>
       <p:sp>
         <p:nvSpPr>
-          <p:cNvPr id="14" name="Überblick Titel"/>
+          <p:cNvPr id="13" name="Überblick Titel"/>
           <p:cNvSpPr txBox="1"/>
           <p:nvPr/>
         </p:nvSpPr>
         <p:spPr>
           <a:xfrm>
-            <a:off x="201168" y="2596896"/>
+            <a:off x="201168" y="2688336"/>
             <a:ext cx="4663440" cy="256032"/>
           </a:xfrm>
           <a:prstGeom prst="rect">
@@ -1563,14 +1506,14 @@
       </p:sp>
       <p:sp>
         <p:nvSpPr>
-          <p:cNvPr id="15" name="Überblick Spalte"/>
+          <p:cNvPr id="14" name="Überblick Spalte"/>
           <p:cNvSpPr txBox="1"/>
           <p:nvPr/>
         </p:nvSpPr>
         <p:spPr>
           <a:xfrm>
-            <a:off x="201168" y="2871216"/>
-            <a:ext cx="2240280" cy="1170432"/>
+            <a:off x="201168" y="2962656"/>
+            <a:ext cx="2240280" cy="1033272"/>
           </a:xfrm>
           <a:prstGeom prst="rect">
             <a:avLst/>
@@ -1668,14 +1611,14 @@
       </p:sp>
       <p:sp>
         <p:nvSpPr>
-          <p:cNvPr id="16" name="Überblick Spalte"/>
+          <p:cNvPr id="15" name="Überblick Spalte"/>
           <p:cNvSpPr txBox="1"/>
           <p:nvPr/>
         </p:nvSpPr>
         <p:spPr>
           <a:xfrm>
-            <a:off x="2624328" y="2871216"/>
-            <a:ext cx="2240280" cy="1170432"/>
+            <a:off x="2624328" y="2962656"/>
+            <a:ext cx="2240280" cy="1033272"/>
           </a:xfrm>
           <a:prstGeom prst="rect">
             <a:avLst/>
@@ -1771,16 +1714,64 @@
           </a:p>
         </p:txBody>
       </p:sp>
-      <p:sp>
-        <p:nvSpPr>
-          <p:cNvPr id="17" name="Abschnittstitel"/>
+      <p:pic>
+        <p:nvPicPr>
+          <p:cNvPr id="16" name="Prozessbild" descr="/tmp/claude-0/-home-user-step2-oneSCM/768b354c-b2c6-524c-b102-2abaf010b0fe/scratchpad/qg/src/img/landscape_01.png">    </p:cNvPr>
+          <p:cNvPicPr>
+            <a:picLocks noChangeAspect="1"/>
+          </p:cNvPicPr>
+          <p:nvPr/>
+        </p:nvPicPr>
+        <p:blipFill>
+          <a:blip r:embed="rId4"/>
+          <a:stretch>
+            <a:fillRect/>
+          </a:stretch>
+        </p:blipFill>
+        <p:spPr>
+          <a:xfrm>
+            <a:off x="201168" y="4105656"/>
+            <a:ext cx="4663440" cy="1207008"/>
+          </a:xfrm>
+          <a:prstGeom prst="rect">
+            <a:avLst/>
+          </a:prstGeom>
+        </p:spPr>
+      </p:pic>
+      <p:pic>
+        <p:nvPicPr>
+          <p:cNvPr id="17" name="Prozessbild" descr="/tmp/claude-0/-home-user-step2-oneSCM/768b354c-b2c6-524c-b102-2abaf010b0fe/scratchpad/qg/src/img/flow_01.png">    </p:cNvPr>
+          <p:cNvPicPr>
+            <a:picLocks noChangeAspect="1"/>
+          </p:cNvPicPr>
+          <p:nvPr/>
+        </p:nvPicPr>
+        <p:blipFill>
+          <a:blip r:embed="rId5"/>
+          <a:stretch>
+            <a:fillRect/>
+          </a:stretch>
+        </p:blipFill>
+        <p:spPr>
+          <a:xfrm>
+            <a:off x="5047488" y="713232"/>
+            <a:ext cx="4663440" cy="960120"/>
+          </a:xfrm>
+          <a:prstGeom prst="rect">
+            <a:avLst/>
+          </a:prstGeom>
+        </p:spPr>
+      </p:pic>
+      <p:sp>
+        <p:nvSpPr>
+          <p:cNvPr id="18" name="Abschnittstitel"/>
           <p:cNvSpPr txBox="1"/>
           <p:nvPr/>
         </p:nvSpPr>
         <p:spPr>
           <a:xfrm>
-            <a:off x="5047488" y="713232"/>
-            <a:ext cx="2816352" cy="256032"/>
+            <a:off x="5047488" y="1783080"/>
+            <a:ext cx="4663440" cy="256032"/>
           </a:xfrm>
           <a:prstGeom prst="rect">
             <a:avLst/>
@@ -1812,14 +1803,14 @@
       </p:sp>
       <p:sp>
         <p:nvSpPr>
-          <p:cNvPr id="18" name="Schritte"/>
+          <p:cNvPr id="19" name="Schritte"/>
           <p:cNvSpPr txBox="1"/>
           <p:nvPr/>
         </p:nvSpPr>
         <p:spPr>
           <a:xfrm>
-            <a:off x="5065776" y="987552"/>
-            <a:ext cx="2798064" cy="1984248"/>
+            <a:off x="5065776" y="2057400"/>
+            <a:ext cx="4645152" cy="1572768"/>
           </a:xfrm>
           <a:prstGeom prst="rect">
             <a:avLst/>
@@ -2050,99 +2041,18 @@
       </p:sp>
       <p:sp>
         <p:nvSpPr>
-          <p:cNvPr id="19" name="Screenshot-Rahmen"/>
+          <p:cNvPr id="20" name="Warnhinweis"/>
           <p:cNvSpPr/>
           <p:nvPr/>
         </p:nvSpPr>
         <p:spPr>
           <a:xfrm>
-            <a:off x="7973568" y="987552"/>
-            <a:ext cx="1737360" cy="1463040"/>
-          </a:xfrm>
-          <a:prstGeom prst="rect">
-            <a:avLst/>
-          </a:prstGeom>
-          <a:solidFill>
-            <a:srgbClr val="F3F3F3"/>
-          </a:solidFill>
-          <a:ln w="6350">
-            <a:solidFill>
-              <a:srgbClr val="BFBFBF"/>
-            </a:solidFill>
-            <a:prstDash val="solid"/>
-          </a:ln>
-        </p:spPr>
-      </p:sp>
-      <p:sp>
-        <p:nvSpPr>
-          <p:cNvPr id="20" name="Screenshot-Beschriftung"/>
-          <p:cNvSpPr txBox="1"/>
-          <p:nvPr/>
-        </p:nvSpPr>
-        <p:spPr>
-          <a:xfrm>
-            <a:off x="7973568" y="987552"/>
-            <a:ext cx="1737360" cy="1463040"/>
-          </a:xfrm>
-          <a:prstGeom prst="rect">
-            <a:avLst/>
-          </a:prstGeom>
-          <a:noFill/>
-          <a:ln/>
-        </p:spPr>
-        <p:txBody>
-          <a:bodyPr wrap="square" lIns="50800" tIns="50800" rIns="50800" bIns="50800" rtlCol="0" anchor="ctr"/>
-          <a:lstStyle/>
-          <a:p>
-            <a:pPr algn="ctr" indent="0" marL="0">
-              <a:buNone/>
-            </a:pPr>
-            <a:r>
-              <a:rPr lang="en-US" sz="700" b="1" dirty="0">
-                <a:solidFill>
-                  <a:srgbClr val="404040"/>
-                </a:solidFill>
-                <a:latin typeface="MB Corpo S Text Office" pitchFamily="34" charset="0"/>
-                <a:ea typeface="MB Corpo S Text Office" pitchFamily="34" charset="-122"/>
-                <a:cs typeface="MB Corpo S Text Office" pitchFamily="34" charset="-120"/>
-              </a:rPr>
-              <a:t>Screenshot</a:t>
-            </a:r>
-            <a:endParaRPr lang="en-US" sz="700" dirty="0"/>
-          </a:p>
-          <a:p>
-            <a:pPr algn="ctr" indent="0" marL="0">
-              <a:buNone/>
-            </a:pPr>
-            <a:r>
-              <a:rPr lang="en-US" sz="700" dirty="0">
-                <a:solidFill>
-                  <a:srgbClr val="404040"/>
-                </a:solidFill>
-                <a:latin typeface="MB Corpo S Text Office" pitchFamily="34" charset="0"/>
-                <a:ea typeface="MB Corpo S Text Office" pitchFamily="34" charset="-122"/>
-                <a:cs typeface="MB Corpo S Text Office" pitchFamily="34" charset="-120"/>
-              </a:rPr>
-              <a:t>Prozesslandkarte</a:t>
-            </a:r>
-            <a:endParaRPr lang="en-US" sz="700" dirty="0"/>
-          </a:p>
-        </p:txBody>
-      </p:sp>
-      <p:sp>
-        <p:nvSpPr>
-          <p:cNvPr id="21" name="Warnhinweis"/>
-          <p:cNvSpPr/>
-          <p:nvPr/>
-        </p:nvSpPr>
-        <p:spPr>
-          <a:xfrm>
-            <a:off x="5047488" y="3081528"/>
-            <a:ext cx="4663440" cy="612648"/>
+            <a:off x="5047488" y="3739896"/>
+            <a:ext cx="4663440" cy="475488"/>
           </a:xfrm>
           <a:prstGeom prst="roundRect">
             <a:avLst>
-              <a:gd name="adj" fmla="val 11940"/>
+              <a:gd name="adj" fmla="val 15385"/>
             </a:avLst>
           </a:prstGeom>
           <a:solidFill>
@@ -2158,14 +2068,14 @@
       </p:sp>
       <p:sp>
         <p:nvSpPr>
-          <p:cNvPr id="22" name="Warnzeichen"/>
+          <p:cNvPr id="21" name="Warnzeichen"/>
           <p:cNvSpPr txBox="1"/>
           <p:nvPr/>
         </p:nvSpPr>
         <p:spPr>
           <a:xfrm>
-            <a:off x="5120640" y="3081528"/>
-            <a:ext cx="274320" cy="612648"/>
+            <a:off x="5120640" y="3739896"/>
+            <a:ext cx="274320" cy="475488"/>
           </a:xfrm>
           <a:prstGeom prst="rect">
             <a:avLst/>
@@ -2197,14 +2107,14 @@
       </p:sp>
       <p:sp>
         <p:nvSpPr>
-          <p:cNvPr id="23" name="Warntext"/>
+          <p:cNvPr id="22" name="Warntext"/>
           <p:cNvSpPr txBox="1"/>
           <p:nvPr/>
         </p:nvSpPr>
         <p:spPr>
           <a:xfrm>
-            <a:off x="5458968" y="3081528"/>
-            <a:ext cx="4160520" cy="612648"/>
+            <a:off x="5458968" y="3739896"/>
+            <a:ext cx="4160520" cy="475488"/>
           </a:xfrm>
           <a:prstGeom prst="rect">
             <a:avLst/>
@@ -2247,13 +2157,13 @@
       </p:sp>
       <p:sp>
         <p:nvSpPr>
-          <p:cNvPr id="24" name="Schritte"/>
+          <p:cNvPr id="23" name="Schritte"/>
           <p:cNvSpPr txBox="1"/>
           <p:nvPr/>
         </p:nvSpPr>
         <p:spPr>
           <a:xfrm>
-            <a:off x="5065776" y="3803904"/>
+            <a:off x="5065776" y="4325112"/>
             <a:ext cx="4645152" cy="694944"/>
           </a:xfrm>
           <a:prstGeom prst="rect">
@@ -2636,11 +2546,11 @@
         <p:spPr>
           <a:xfrm>
             <a:off x="201168" y="713232"/>
-            <a:ext cx="4663440" cy="2130552"/>
+            <a:ext cx="4663440" cy="2286000"/>
           </a:xfrm>
           <a:prstGeom prst="roundRect">
             <a:avLst>
-              <a:gd name="adj" fmla="val 4292"/>
+              <a:gd name="adj" fmla="val 4000"/>
             </a:avLst>
           </a:prstGeom>
           <a:solidFill>
@@ -2704,7 +2614,7 @@
         <p:spPr>
           <a:xfrm>
             <a:off x="310896" y="1060704"/>
-            <a:ext cx="4480560" cy="1728216"/>
+            <a:ext cx="4480560" cy="1883664"/>
           </a:xfrm>
           <a:prstGeom prst="rect">
             <a:avLst/>
@@ -2976,12 +2886,12 @@
         </p:nvSpPr>
         <p:spPr>
           <a:xfrm>
-            <a:off x="201168" y="2953512"/>
-            <a:ext cx="4663440" cy="1115568"/>
+            <a:off x="201168" y="3108960"/>
+            <a:ext cx="4663440" cy="1197864"/>
           </a:xfrm>
           <a:prstGeom prst="roundRect">
             <a:avLst>
-              <a:gd name="adj" fmla="val 8197"/>
+              <a:gd name="adj" fmla="val 7634"/>
             </a:avLst>
           </a:prstGeom>
           <a:solidFill>
@@ -3005,7 +2915,7 @@
         </p:nvSpPr>
         <p:spPr>
           <a:xfrm>
-            <a:off x="310896" y="3026664"/>
+            <a:off x="310896" y="3182112"/>
             <a:ext cx="4480560" cy="256032"/>
           </a:xfrm>
           <a:prstGeom prst="rect">
@@ -3044,8 +2954,8 @@
         </p:nvSpPr>
         <p:spPr>
           <a:xfrm>
-            <a:off x="310896" y="3300984"/>
-            <a:ext cx="4480560" cy="713232"/>
+            <a:off x="310896" y="3456432"/>
+            <a:ext cx="4480560" cy="795528"/>
           </a:xfrm>
           <a:prstGeom prst="rect">
             <a:avLst/>
@@ -3150,12 +3060,12 @@
         </p:nvSpPr>
         <p:spPr>
           <a:xfrm>
-            <a:off x="201168" y="4178808"/>
-            <a:ext cx="4663440" cy="1225296"/>
+            <a:off x="201168" y="4416552"/>
+            <a:ext cx="4663440" cy="1170432"/>
           </a:xfrm>
           <a:prstGeom prst="roundRect">
             <a:avLst>
-              <a:gd name="adj" fmla="val 7463"/>
+              <a:gd name="adj" fmla="val 7813"/>
             </a:avLst>
           </a:prstGeom>
           <a:solidFill>
@@ -3179,7 +3089,7 @@
         </p:nvSpPr>
         <p:spPr>
           <a:xfrm>
-            <a:off x="310896" y="4251960"/>
+            <a:off x="310896" y="4489704"/>
             <a:ext cx="4480560" cy="256032"/>
           </a:xfrm>
           <a:prstGeom prst="rect">
@@ -3218,8 +3128,8 @@
         </p:nvSpPr>
         <p:spPr>
           <a:xfrm>
-            <a:off x="310896" y="4526280"/>
-            <a:ext cx="4480560" cy="822960"/>
+            <a:off x="310896" y="4764024"/>
+            <a:ext cx="4480560" cy="768096"/>
           </a:xfrm>
           <a:prstGeom prst="rect">
             <a:avLst/>
@@ -3471,11 +3381,11 @@
         <p:spPr>
           <a:xfrm>
             <a:off x="5047488" y="2221992"/>
-            <a:ext cx="4663440" cy="1389888"/>
+            <a:ext cx="4663440" cy="1490472"/>
           </a:xfrm>
           <a:prstGeom prst="roundRect">
             <a:avLst>
-              <a:gd name="adj" fmla="val 6579"/>
+              <a:gd name="adj" fmla="val 6135"/>
             </a:avLst>
           </a:prstGeom>
           <a:solidFill>
@@ -3539,7 +3449,7 @@
         <p:spPr>
           <a:xfrm>
             <a:off x="5157216" y="2569464"/>
-            <a:ext cx="4480560" cy="987552"/>
+            <a:ext cx="4480560" cy="1088136"/>
           </a:xfrm>
           <a:prstGeom prst="rect">
             <a:avLst/>

</xml_diff>

<commit_message>
Quick Guides für Anhänge, Übergangsmodule und Vorspann
20 weitere Guides (A.1 bis I.3, T6-7 bis T15-16, V.1 und V.2) im selben
Layout; Prozesslandkarte hebt bei Übergangsmodulen beide Kapitel hervor.
Gesamt-PDF jetzt mit 43 Guides auf 86 Seiten.

Co-Authored-By: Claude Fable 5.1 <noreply@anthropic.com>
Claude-Session: https://claude.ai/code/session_01EhK4mVLcbJ5LMGgA3j15g8
</commit_message>
<xml_diff>
--- a/docs/quickguides/pptx/01_Quick_Guide_oneSCM_Einfuehrung_und_Ueberblick.pptx
+++ b/docs/quickguides/pptx/01_Quick_Guide_oneSCM_Einfuehrung_und_Ueberblick.pptx
@@ -1159,7 +1159,7 @@
                 <a:ea typeface="MB Corpo S Text Office" pitchFamily="34" charset="-122"/>
                 <a:cs typeface="MB Corpo S Text Office" pitchFamily="34" charset="-120"/>
               </a:rPr>
-              <a:t>: Dieser Quick Guide fasst Kapitel 1 des oneSCM-Handbuchs zusammen. Details, Bildschirmbilder und Nachweise finden Sie im Handbuchkapitel.</a:t>
+              <a:t>: Dieser Quick Guide fasst Kapitel 1 des oneSCM-Handbuchs zusammen. Details, Bildschirmbilder und Nachweise finden Sie im Handbuch.</a:t>
             </a:r>
             <a:endParaRPr lang="en-US" sz="800" dirty="0"/>
           </a:p>
@@ -2492,7 +2492,7 @@
                 <a:ea typeface="MB Corpo S Text Office" pitchFamily="34" charset="-122"/>
                 <a:cs typeface="MB Corpo S Text Office" pitchFamily="34" charset="-120"/>
               </a:rPr>
-              <a:t>: Dieser Quick Guide fasst Kapitel 1 des oneSCM-Handbuchs zusammen. Details, Bildschirmbilder und Nachweise finden Sie im Handbuchkapitel.</a:t>
+              <a:t>: Dieser Quick Guide fasst Kapitel 1 des oneSCM-Handbuchs zusammen. Details, Bildschirmbilder und Nachweise finden Sie im Handbuch.</a:t>
             </a:r>
             <a:endParaRPr lang="en-US" sz="800" dirty="0"/>
           </a:p>

</xml_diff>